<commit_message>
feat(els): 제38190~38202회 13종 세일즈 자료 3종 (자동 빌드)
러너가 수집·파싱·대장 검산·빌드·역방향 대조까지 끝낸 판이다. 눈으로 보는 검증은 아직 안 했다 — 예약 세션이 받아서 확인하고 사용자에게 보낸다.

접수번호 20261008000217
</commit_message>
<xml_diff>
--- a/els-analysis-deck.pptx
+++ b/els-analysis-deck.pptx
@@ -5279,7 +5279,7 @@
                 <a:ea typeface="맑은 고딕" pitchFamily="34" charset="-122"/>
                 <a:cs typeface="맑은 고딕" pitchFamily="34" charset="-120"/>
               </a:rPr>
-              <a:t>홈페이지 확인 2026.10.13(화) 12:26 — 현재 청약 진행중 34건.  개인 일반투자자 청약 마감은 10월 16일(금)입니다.</a:t>
+              <a:t>홈페이지 확인 2026.10.13(화) 12:37 — 현재 청약 진행중 34건.  개인 일반투자자 청약 마감은 10월 16일(금)입니다.</a:t>
             </a:r>
             <a:endParaRPr lang="en-US" sz="1200" dirty="0"/>
           </a:p>
@@ -6827,7 +6827,7 @@
                 <a:ea typeface="맑은 고딕" pitchFamily="34" charset="-122"/>
                 <a:cs typeface="맑은 고딕" pitchFamily="34" charset="-120"/>
               </a:rPr>
-              <a:t>지는 위험 1%당 받는 수익률이 이번 회차에서 가장 큽니다 — 같은 위험이면 여기가 제일 많이 줍니다.</a:t>
+              <a:t>지는 위험 1%당 받는 수익률이 앞 자리에 오른 제38194회 다음으로 큽니다 — 같은 위험이면 그만큼 많이 줍니다.</a:t>
             </a:r>
             <a:endParaRPr lang="en-US" sz="1150" dirty="0"/>
           </a:p>
@@ -8414,7 +8414,7 @@
                 <a:ea typeface="맑은 고딕" pitchFamily="34" charset="-122"/>
                 <a:cs typeface="맑은 고딕" pitchFamily="34" charset="-120"/>
               </a:rPr>
-              <a:t>넣는 순간의 값어치가 크게 깎이지 않은 상품 중에서 골랐습니다. 이보다 높은 제38195회(연 13%)는 바로 위 자리에 이미 올라 있어, 그다음으로 높은 수익률입니다.</a:t>
+              <a:t>넣는 순간의 값어치가 크게 깎이지 않은 상품 중에서 골랐습니다. 이보다 높은 제38195회(연 13%)·제38194회(연 12%)는 앞 자리에 이미 올라 있어, 그다음으로 높은 수익률입니다.</a:t>
             </a:r>
             <a:endParaRPr lang="en-US" sz="1150" dirty="0"/>
           </a:p>
@@ -32323,7 +32323,7 @@
                 <a:ea typeface="맑은 고딕" pitchFamily="34" charset="-122"/>
                 <a:cs typeface="맑은 고딕" pitchFamily="34" charset="-120"/>
               </a:rPr>
-              <a:t>그런데 상품 하나하나로 내려가면 뒤집힙니다. 지수만 담은 제38193회가 18.6%로 종목 섞인 상품 대부분보다 위험하고, 제38194회는 11.3%로 13종 중 1번째로 낮습니다.</a:t>
+              <a:t>그런데 상품 하나하나로 내려가면 뒤집힙니다. 지수만 담은 제38193회가 18.6%로 종목 섞인 제38194·38195·38196회보다 위험하고, 제38194회는 11.3%로 13종 중 가장 낮습니다.</a:t>
             </a:r>
             <a:endParaRPr lang="en-US" sz="1250" dirty="0"/>
           </a:p>
@@ -33864,7 +33864,7 @@
                 <a:ea typeface="맑은 고딕" pitchFamily="34" charset="-122"/>
                 <a:cs typeface="맑은 고딕" pitchFamily="34" charset="-120"/>
               </a:rPr>
-              <a:t>수익률 1%p당 손실 확률 +-0.19%p — 방향은 맞지만 상품마다 그 몇 배씩 들쭉날쭉합니다</a:t>
+              <a:t>값어치 멀쩡한 6종만 보면 수익률을 1%p 더 받는 상품의 손실 확률이 평균 0.19%p 오히려 낮게 나옵니다 — 수익률로는 위험을 가늠할 수 없습니다</a:t>
             </a:r>
             <a:endParaRPr lang="en-US" sz="1000" dirty="0"/>
           </a:p>
@@ -35552,7 +35552,7 @@
                 <a:ea typeface="맑은 고딕" pitchFamily="34" charset="-122"/>
                 <a:cs typeface="맑은 고딕" pitchFamily="34" charset="-120"/>
               </a:rPr>
-              <a:t>제38202회는 연 23.5%인데 손실 확률이 57.6%나 됩니다 — 손실 확률 1%당 0.41%로 이번 회차 꼴찌입니다. 넣는 순간의 값어치가 제값보다 37.1%나 깎여 있기 때문입니다.</a:t>
+              <a:t>제38202회는 연 23.5%인데 손실 확률이 57.6%나 됩니다 — 손실 확률 1%당 0.41%뿐입니다. 넣는 순간의 값어치가 제값보다 37.1%나 깎여 있기 때문입니다.</a:t>
             </a:r>
             <a:endParaRPr lang="en-US" sz="1000" dirty="0"/>
           </a:p>
@@ -37118,7 +37118,7 @@
                 <a:ea typeface="맑은 고딕" pitchFamily="34" charset="-122"/>
                 <a:cs typeface="맑은 고딕" pitchFamily="34" charset="-120"/>
               </a:rPr>
-              <a:t>같이 움직이는 정도를 0.50까지 억지로 낮춰도 손실 확률은 11.4% → 14.8% 오르는 데 그치고, 손실 확률 1%당 수익률은 0.81%로 여전히 이번 회차 1등입니다. 두 기초자산의 변동성이 8.6%p나 벌어져 있어서, 같이 움직이든 말든 "더 나쁜 쪽"이 거의 항상 같은 자산이기 때문입니다. 변동성이 비슷한 짝이었다면 이렇게 버티지 못합니다.</a:t>
+              <a:t>같이 움직이는 정도를 0.50까지 낮추면 손실 확률은 11.4% → 14.8%로 오르고, 손실 확률 1%당 수익률은 0.81%로 내려가 제38195회에 1등을 내줍니다. 이 상품의 우위는 두 자산이 서류값 0.88만큼 같이 움직인다는 전제에 기대고 있습니다.</a:t>
             </a:r>
             <a:endParaRPr lang="en-US" sz="1000" dirty="0"/>
           </a:p>

</xml_diff>

<commit_message>
feat(els): 제38205~38223회 19종 세일즈 자료 3종 (자동 빌드)
러너가 수집·파싱·대장 검산·빌드·역방향 대조까지 끝낸 판이다. 눈으로 보는 검증은 아직 안 했다 — 예약 세션이 받아서 확인하고 사용자에게 보낸다.

접수번호 20261016000319,20261014000084
</commit_message>
<xml_diff>
--- a/els-analysis-deck.pptx
+++ b/els-analysis-deck.pptx
@@ -5051,7 +5051,7 @@
           <a:p>
             <a:r>
               <a:rPr lang="en-US" dirty="0"/>
-              <a:t>마감일을 잘못 안내하면 고객이 청약 기회를 놓칩니다. 홈페이지의 2026.10.28이 아니라 10월 23일(금)이 개인 일반투자자의 마감입니다.</a:t>
+              <a:t>마감일을 잘못 안내하면 고객이 청약 기회를 놓칩니다. 홈페이지의 2026.10.28이 아니라 10월 23일(금)이 개인 일반투자자의 마감입니다. 단, 제38222·38223회는 별도 공시(청약 2026.10.15~2026.10.22)라 개인 일반투자자 마감이 10월 19일(월)로 이미 지났습니다.</a:t>
             </a:r>
             <a:endParaRPr lang="en-US" dirty="0"/>
           </a:p>
@@ -6441,7 +6441,46 @@
       </p:sp>
       <p:sp>
         <p:nvSpPr>
-          <p:cNvPr id="12" name="Shape 10"/>
+          <p:cNvPr id="12" name="Text 10"/>
+          <p:cNvSpPr/>
+          <p:nvPr/>
+        </p:nvSpPr>
+        <p:spPr>
+          <a:xfrm>
+            <a:off x="7955280" y="4242816"/>
+            <a:ext cx="3657600" cy="457200"/>
+          </a:xfrm>
+          <a:prstGeom prst="rect">
+            <a:avLst/>
+          </a:prstGeom>
+          <a:noFill/>
+          <a:ln/>
+        </p:spPr>
+        <p:txBody>
+          <a:bodyPr wrap="square" lIns="0" tIns="0" rIns="0" bIns="0" rtlCol="0" anchor="t"/>
+          <a:lstStyle/>
+          <a:p>
+            <a:pPr indent="0" marL="0">
+              <a:buNone/>
+            </a:pPr>
+            <a:r>
+              <a:rPr lang="en-US" sz="1000" b="1" dirty="0">
+                <a:solidFill>
+                  <a:srgbClr val="FFFFFF"/>
+                </a:solidFill>
+                <a:latin typeface="맑은 고딕" pitchFamily="34" charset="0"/>
+                <a:ea typeface="맑은 고딕" pitchFamily="34" charset="-122"/>
+                <a:cs typeface="맑은 고딕" pitchFamily="34" charset="-120"/>
+              </a:rPr>
+              <a:t>제38222·38223회는 별도 공시 — 개인 마감 2026.10.19(지남), 전체 2026.10.15~2026.10.22</a:t>
+            </a:r>
+            <a:endParaRPr lang="en-US" sz="1000" dirty="0"/>
+          </a:p>
+        </p:txBody>
+      </p:sp>
+      <p:sp>
+        <p:nvSpPr>
+          <p:cNvPr id="13" name="Shape 11"/>
           <p:cNvSpPr/>
           <p:nvPr/>
         </p:nvSpPr>
@@ -6466,7 +6505,7 @@
       </p:sp>
       <p:sp>
         <p:nvSpPr>
-          <p:cNvPr id="13" name="Text 11"/>
+          <p:cNvPr id="14" name="Text 12"/>
           <p:cNvSpPr/>
           <p:nvPr/>
         </p:nvSpPr>
@@ -6505,7 +6544,7 @@
       </p:sp>
       <p:sp>
         <p:nvSpPr>
-          <p:cNvPr id="14" name="Text 12"/>
+          <p:cNvPr id="15" name="Text 13"/>
           <p:cNvSpPr/>
           <p:nvPr/>
         </p:nvSpPr>
@@ -6590,7 +6629,7 @@
       </p:sp>
       <p:sp>
         <p:nvSpPr>
-          <p:cNvPr id="15" name="Text 13"/>
+          <p:cNvPr id="16" name="Text 14"/>
           <p:cNvSpPr/>
           <p:nvPr/>
         </p:nvSpPr>
@@ -6675,7 +6714,7 @@
       </p:sp>
       <p:sp>
         <p:nvSpPr>
-          <p:cNvPr id="16" name="Text 14"/>
+          <p:cNvPr id="17" name="Text 15"/>
           <p:cNvSpPr/>
           <p:nvPr/>
         </p:nvSpPr>
@@ -6760,7 +6799,7 @@
       </p:sp>
       <p:sp>
         <p:nvSpPr>
-          <p:cNvPr id="17" name="Text 15"/>
+          <p:cNvPr id="18" name="Text 16"/>
           <p:cNvSpPr/>
           <p:nvPr/>
         </p:nvSpPr>
@@ -6791,7 +6830,7 @@
                 <a:ea typeface="맑은 고딕" pitchFamily="34" charset="-122"/>
                 <a:cs typeface="맑은 고딕" pitchFamily="34" charset="-120"/>
               </a:rPr>
-              <a:t>홈페이지 확인 2026.10.19(월) 15:04 — 현재 청약 진행중 34건.  개인 일반투자자 청약 마감은 10월 23일(금)입니다.</a:t>
+              <a:t>홈페이지 확인 2026.10.20(화) 11:12 — 현재 청약 진행중 34건.  개인 일반투자자 청약 마감은 10월 23일(금)입니다.</a:t>
             </a:r>
             <a:endParaRPr lang="en-US" sz="1200" dirty="0"/>
           </a:p>
@@ -6799,7 +6838,7 @@
       </p:sp>
       <p:sp>
         <p:nvSpPr>
-          <p:cNvPr id="18" name="Text 16"/>
+          <p:cNvPr id="19" name="Text 17"/>
           <p:cNvSpPr/>
           <p:nvPr/>
         </p:nvSpPr>
@@ -8261,7 +8300,7 @@
                 <a:ea typeface="맑은 고딕" pitchFamily="34" charset="-122"/>
                 <a:cs typeface="맑은 고딕" pitchFamily="34" charset="-120"/>
               </a:rPr>
-              <a:t>둘이 같이 움직임 0.22</a:t>
+              <a:t>가장 따로 노는 쌍 0.22</a:t>
             </a:r>
             <a:endParaRPr lang="en-US" sz="950" dirty="0"/>
           </a:p>
@@ -8378,7 +8417,7 @@
                 <a:ea typeface="맑은 고딕" pitchFamily="34" charset="-122"/>
                 <a:cs typeface="맑은 고딕" pitchFamily="34" charset="-120"/>
               </a:rPr>
-              <a:t>출처 — 금융감독원 전자공시시스템(DART)에 2026.10.16 올라온 투자설명서 (접수번호 20261016000319)  ·  원금을 잃을 수 있는 상품입니다</a:t>
+              <a:t>출처 — 금융감독원 전자공시시스템(DART)에 2026.10.16·2026.10.14 올라온 투자설명서 (접수번호 20261016000319 · 20261014000084)  ·  원금을 잃을 수 있는 상품입니다</a:t>
             </a:r>
             <a:endParaRPr lang="en-US" sz="850" dirty="0"/>
           </a:p>
@@ -9848,7 +9887,7 @@
                 <a:ea typeface="맑은 고딕" pitchFamily="34" charset="-122"/>
                 <a:cs typeface="맑은 고딕" pitchFamily="34" charset="-120"/>
               </a:rPr>
-              <a:t>둘이 같이 움직임 0.17</a:t>
+              <a:t>가장 따로 노는 쌍 0.17</a:t>
             </a:r>
             <a:endParaRPr lang="en-US" sz="950" dirty="0"/>
           </a:p>
@@ -9965,7 +10004,7 @@
                 <a:ea typeface="맑은 고딕" pitchFamily="34" charset="-122"/>
                 <a:cs typeface="맑은 고딕" pitchFamily="34" charset="-120"/>
               </a:rPr>
-              <a:t>출처 — 금융감독원 전자공시시스템(DART)에 2026.10.16 올라온 투자설명서 (접수번호 20261016000319)  ·  원금을 잃을 수 있는 상품입니다</a:t>
+              <a:t>출처 — 금융감독원 전자공시시스템(DART)에 2026.10.16·2026.10.14 올라온 투자설명서 (접수번호 20261016000319 · 20261014000084)  ·  원금을 잃을 수 있는 상품입니다</a:t>
             </a:r>
             <a:endParaRPr lang="en-US" sz="850" dirty="0"/>
           </a:p>
@@ -27290,7 +27329,7 @@
                 <a:ea typeface="맑은 고딕" pitchFamily="34" charset="-122"/>
                 <a:cs typeface="맑은 고딕" pitchFamily="34" charset="-120"/>
               </a:rPr>
-              <a:t>출처 — 금융감독원 전자공시시스템(DART)에 2026.10.16 올라온 투자설명서 (접수번호 20261016000319)  ·  원금을 잃을 수 있는 상품입니다</a:t>
+              <a:t>출처 — 금융감독원 전자공시시스템(DART)에 2026.10.16·2026.10.14 올라온 투자설명서 (접수번호 20261016000319 · 20261014000084)  ·  원금을 잃을 수 있는 상품입니다</a:t>
             </a:r>
             <a:endParaRPr lang="en-US" sz="850" dirty="0"/>
           </a:p>
@@ -28520,7 +28559,7 @@
                 <a:ea typeface="맑은 고딕" pitchFamily="34" charset="-122"/>
                 <a:cs typeface="맑은 고딕" pitchFamily="34" charset="-120"/>
               </a:rPr>
-              <a:t>출처 — 금융감독원 전자공시시스템(DART)에 2026.10.16 올라온 투자설명서 (접수번호 20261016000319)  ·  원금을 잃을 수 있는 상품입니다</a:t>
+              <a:t>출처 — 금융감독원 전자공시시스템(DART)에 2026.10.16·2026.10.14 올라온 투자설명서 (접수번호 20261016000319 · 20261014000084)  ·  원금을 잃을 수 있는 상품입니다</a:t>
             </a:r>
             <a:endParaRPr lang="en-US" sz="850" dirty="0"/>
           </a:p>
@@ -28835,7 +28874,7 @@
                 <a:ea typeface="맑은 고딕" pitchFamily="34" charset="-122"/>
                 <a:cs typeface="맑은 고딕" pitchFamily="34" charset="-120"/>
               </a:rPr>
-              <a:t>홈페이지에는 2026.10.19~2026.10.28로 나오지만 개인 일반투자자는 10월 23일(금)까지만 청약할 수 있습니다. 이후는 숙려·가입의사확인 기간이라 주문을 받을 수 없습니다.</a:t>
+              <a:t>홈페이지에는 2026.10.19~2026.10.28로 나오지만 개인 일반투자자는 10월 23일(금)까지만 청약할 수 있습니다. 이후는 숙려·가입의사확인 기간이라 주문을 받을 수 없습니다. 단, 제38222·38223회는 별도 공시(청약 2026.10.15~2026.10.22)라 개인 일반투자자 마감이 10월 19일(월)로 이미 지났습니다.</a:t>
             </a:r>
             <a:endParaRPr lang="en-US" sz="1100" dirty="0"/>
           </a:p>
@@ -29614,7 +29653,7 @@
                 <a:ea typeface="맑은 고딕" pitchFamily="34" charset="-122"/>
                 <a:cs typeface="맑은 고딕" pitchFamily="34" charset="-120"/>
               </a:rPr>
-              <a:t>출처 — 금융감독원 전자공시시스템(DART)에 2026.10.16 올라온 투자설명서 (접수번호 20261016000319)  ·  원금을 잃을 수 있는 상품입니다</a:t>
+              <a:t>출처 — 금융감독원 전자공시시스템(DART)에 2026.10.16·2026.10.14 올라온 투자설명서 (접수번호 20261016000319 · 20261014000084)  ·  원금을 잃을 수 있는 상품입니다</a:t>
             </a:r>
             <a:endParaRPr lang="en-US" sz="850" dirty="0"/>
           </a:p>
@@ -30752,7 +30791,7 @@
                 <a:ea typeface="맑은 고딕" pitchFamily="34" charset="-122"/>
                 <a:cs typeface="맑은 고딕" pitchFamily="34" charset="-120"/>
               </a:rPr>
-              <a:t>출처 — 금융감독원 전자공시시스템(DART)에 2026.10.16 올라온 투자설명서 (접수번호 20261016000319)  ·  원금을 잃을 수 있는 상품입니다</a:t>
+              <a:t>출처 — 금융감독원 전자공시시스템(DART)에 2026.10.16·2026.10.14 올라온 투자설명서 (접수번호 20261016000319 · 20261014000084)  ·  원금을 잃을 수 있는 상품입니다</a:t>
             </a:r>
             <a:endParaRPr lang="en-US" sz="850" dirty="0"/>
           </a:p>
@@ -34190,7 +34229,7 @@
                 <a:ea typeface="맑은 고딕" pitchFamily="34" charset="-122"/>
                 <a:cs typeface="맑은 고딕" pitchFamily="34" charset="-120"/>
               </a:rPr>
-              <a:t>출처 — 금융감독원 전자공시시스템(DART)에 2026.10.16 올라온 투자설명서 (접수번호 20261016000319)  ·  원금을 잃을 수 있는 상품입니다</a:t>
+              <a:t>출처 — 금융감독원 전자공시시스템(DART)에 2026.10.16·2026.10.14 올라온 투자설명서 (접수번호 20261016000319 · 20261014000084)  ·  원금을 잃을 수 있는 상품입니다</a:t>
             </a:r>
             <a:endParaRPr lang="en-US" sz="850" dirty="0"/>
           </a:p>
@@ -35480,7 +35519,46 @@
       </p:sp>
       <p:sp>
         <p:nvSpPr>
-          <p:cNvPr id="37" name="Text 34"/>
+          <p:cNvPr id="36" name="Text 34"/>
+          <p:cNvSpPr/>
+          <p:nvPr/>
+        </p:nvSpPr>
+        <p:spPr>
+          <a:xfrm>
+            <a:off x="566928" y="5669280"/>
+            <a:ext cx="11057839" cy="274320"/>
+          </a:xfrm>
+          <a:prstGeom prst="rect">
+            <a:avLst/>
+          </a:prstGeom>
+          <a:noFill/>
+          <a:ln/>
+        </p:spPr>
+        <p:txBody>
+          <a:bodyPr wrap="square" lIns="0" tIns="0" rIns="0" bIns="0" rtlCol="0" anchor="ctr"/>
+          <a:lstStyle/>
+          <a:p>
+            <a:pPr indent="0" marL="0">
+              <a:buNone/>
+            </a:pPr>
+            <a:r>
+              <a:rPr lang="en-US" sz="1050" b="1" dirty="0">
+                <a:solidFill>
+                  <a:srgbClr val="CB6015"/>
+                </a:solidFill>
+                <a:latin typeface="맑은 고딕" pitchFamily="34" charset="0"/>
+                <a:ea typeface="맑은 고딕" pitchFamily="34" charset="-122"/>
+                <a:cs typeface="맑은 고딕" pitchFamily="34" charset="-120"/>
+              </a:rPr>
+              <a:t>단, 제38222·38223회는 별도 공시(청약 2026.10.15~2026.10.22)라 개인 일반투자자 마감이 10월 19일(월)로 이미 지났습니다.</a:t>
+            </a:r>
+            <a:endParaRPr lang="en-US" sz="1050" dirty="0"/>
+          </a:p>
+        </p:txBody>
+      </p:sp>
+      <p:sp>
+        <p:nvSpPr>
+          <p:cNvPr id="38" name="Text 35"/>
           <p:cNvSpPr/>
           <p:nvPr/>
         </p:nvSpPr>
@@ -35511,7 +35589,7 @@
                 <a:ea typeface="맑은 고딕" pitchFamily="34" charset="-122"/>
                 <a:cs typeface="맑은 고딕" pitchFamily="34" charset="-120"/>
               </a:rPr>
-              <a:t>출처 — 금융감독원 전자공시시스템(DART)에 2026.10.16 올라온 투자설명서 (접수번호 20261016000319)  ·  원금을 잃을 수 있는 상품입니다</a:t>
+              <a:t>출처 — 금융감독원 전자공시시스템(DART)에 2026.10.16·2026.10.14 올라온 투자설명서 (접수번호 20261016000319 · 20261014000084)  ·  원금을 잃을 수 있는 상품입니다</a:t>
             </a:r>
             <a:endParaRPr lang="en-US" sz="850" dirty="0"/>
           </a:p>
@@ -35519,7 +35597,7 @@
       </p:sp>
       <p:sp>
         <p:nvSpPr>
-          <p:cNvPr id="38" name="Text 35"/>
+          <p:cNvPr id="39" name="Text 36"/>
           <p:cNvSpPr/>
           <p:nvPr/>
         </p:nvSpPr>
@@ -36403,7 +36481,7 @@
                 <a:ea typeface="맑은 고딕" pitchFamily="34" charset="-122"/>
                 <a:cs typeface="맑은 고딕" pitchFamily="34" charset="-120"/>
               </a:rPr>
-              <a:t>출처 — 금융감독원 전자공시시스템(DART)에 2026.10.16 올라온 투자설명서 (접수번호 20261016000319)  ·  원금을 잃을 수 있는 상품입니다</a:t>
+              <a:t>출처 — 금융감독원 전자공시시스템(DART)에 2026.10.16·2026.10.14 올라온 투자설명서 (접수번호 20261016000319 · 20261014000084)  ·  원금을 잃을 수 있는 상품입니다</a:t>
             </a:r>
             <a:endParaRPr lang="en-US" sz="850" dirty="0"/>
           </a:p>
@@ -37507,7 +37585,7 @@
                 <a:ea typeface="맑은 고딕" pitchFamily="34" charset="-122"/>
                 <a:cs typeface="맑은 고딕" pitchFamily="34" charset="-120"/>
               </a:rPr>
-              <a:t>출처 — 금융감독원 전자공시시스템(DART)에 2026.10.16 올라온 투자설명서 (접수번호 20261016000319)  ·  원금을 잃을 수 있는 상품입니다</a:t>
+              <a:t>출처 — 금융감독원 전자공시시스템(DART)에 2026.10.16·2026.10.14 올라온 투자설명서 (접수번호 20261016000319 · 20261014000084)  ·  원금을 잃을 수 있는 상품입니다</a:t>
             </a:r>
             <a:endParaRPr lang="en-US" sz="850" dirty="0"/>
           </a:p>
@@ -39140,7 +39218,7 @@
                 <a:ea typeface="맑은 고딕" pitchFamily="34" charset="-122"/>
                 <a:cs typeface="맑은 고딕" pitchFamily="34" charset="-120"/>
               </a:rPr>
-              <a:t>실제로 갈라놓은 건 자산 종류가 아니라 "원금 지키는 선이 얼마나 아래인가"와 "두 자산이 얼마나 같이 움직이는가"였습니다. 제38222회는 선이 45%(이번 주에서 높은 축이라 여유가 적음)에 같이 움직임 0.16, 제38213회는 선이 35%에 같이 움직임 0.96입니다.</a:t>
+              <a:t>실제로 갈라놓은 건 자산 종류가 아니라 "원금 지키는 선이 얼마나 아래인가"와 "기초자산끼리 얼마나 같이 움직이는가"였습니다. 제38222회는 선이 45%(이번 주에서 높은 축이라 여유가 적음)에 가장 따로 노는 쌍 0.16, 제38213회는 선이 35%에 같이 움직임 0.96입니다.</a:t>
             </a:r>
             <a:endParaRPr lang="en-US" sz="1250" dirty="0"/>
           </a:p>
@@ -39207,7 +39285,7 @@
                 <a:ea typeface="맑은 고딕" pitchFamily="34" charset="-122"/>
                 <a:cs typeface="맑은 고딕" pitchFamily="34" charset="-120"/>
               </a:rPr>
-              <a:t>두 자산이 따로 놀수록 "더 많이 떨어진 하나로 판정한다"는 조건에서 크게 불리해집니다. 무엇을 담았느냐보다 이쪽이 결정적입니다.</a:t>
+              <a:t>기초자산끼리 따로 놀수록 "더 많이 떨어진 하나로 판정한다"는 조건에서 크게 불리해집니다. 무엇을 담았느냐보다 이쪽이 결정적입니다.</a:t>
             </a:r>
             <a:endParaRPr lang="en-US" sz="1150" dirty="0"/>
           </a:p>
@@ -39246,7 +39324,7 @@
                 <a:ea typeface="맑은 고딕" pitchFamily="34" charset="-122"/>
                 <a:cs typeface="맑은 고딕" pitchFamily="34" charset="-120"/>
               </a:rPr>
-              <a:t>출처 — 금융감독원 전자공시시스템(DART)에 2026.10.16 올라온 투자설명서 (접수번호 20261016000319)  ·  원금을 잃을 수 있는 상품입니다</a:t>
+              <a:t>출처 — 금융감독원 전자공시시스템(DART)에 2026.10.16·2026.10.14 올라온 투자설명서 (접수번호 20261016000319 · 20261014000084)  ·  원금을 잃을 수 있는 상품입니다</a:t>
             </a:r>
             <a:endParaRPr lang="en-US" sz="850" dirty="0"/>
           </a:p>
@@ -41053,7 +41131,7 @@
                 <a:ea typeface="맑은 고딕" pitchFamily="34" charset="-122"/>
                 <a:cs typeface="맑은 고딕" pitchFamily="34" charset="-120"/>
               </a:rPr>
-              <a:t>출처 — 금융감독원 전자공시시스템(DART)에 2026.10.16 올라온 투자설명서 (접수번호 20261016000319)  ·  원금을 잃을 수 있는 상품입니다</a:t>
+              <a:t>출처 — 금융감독원 전자공시시스템(DART)에 2026.10.16·2026.10.14 올라온 투자설명서 (접수번호 20261016000319 · 20261014000084)  ·  원금을 잃을 수 있는 상품입니다</a:t>
             </a:r>
             <a:endParaRPr lang="en-US" sz="850" dirty="0"/>
           </a:p>
@@ -41559,7 +41637,7 @@
                 <a:ea typeface="맑은 고딕" pitchFamily="34" charset="-122"/>
                 <a:cs typeface="맑은 고딕" pitchFamily="34" charset="-120"/>
               </a:rPr>
-              <a:t>같은 위험을 지고 가장 많이 받는 쪽은 제38207회(연 9.4% · 손실 확률 13.6%)입니다.</a:t>
+              <a:t>같은 위험을 지고 가장 많이 받는 쪽은 값어치 멀쩡한 상품 중에서 제38207회(연 9.4% · 손실 확률 13.6%)입니다.</a:t>
             </a:r>
             <a:endParaRPr lang="en-US" sz="1000" dirty="0"/>
           </a:p>
@@ -41860,7 +41938,7 @@
                 <a:ea typeface="맑은 고딕" pitchFamily="34" charset="-122"/>
                 <a:cs typeface="맑은 고딕" pitchFamily="34" charset="-120"/>
               </a:rPr>
-              <a:t>출처 — 금융감독원 전자공시시스템(DART)에 2026.10.16 올라온 투자설명서 (접수번호 20261016000319)  ·  원금을 잃을 수 있는 상품입니다</a:t>
+              <a:t>출처 — 금융감독원 전자공시시스템(DART)에 2026.10.16·2026.10.14 올라온 투자설명서 (접수번호 20261016000319 · 20261014000084)  ·  원금을 잃을 수 있는 상품입니다</a:t>
             </a:r>
             <a:endParaRPr lang="en-US" sz="850" dirty="0"/>
           </a:p>
@@ -42147,7 +42225,7 @@
                 <a:ea typeface="맑은 고딕" pitchFamily="34" charset="-122"/>
                 <a:cs typeface="맑은 고딕" pitchFamily="34" charset="-120"/>
               </a:rPr>
-              <a:t>삼성전자·SK하이닉스 4종은 기초자산도, 적용 변동성(56.8%)도, 기간(36개월)도 똑같은데 수익률만 갈립니다.</a:t>
+              <a:t>삼성전자·SK하이닉스 4종은 기초자산도, 기간(36개월)도 똑같고 적용 변동성도 56.8~57.4%로 거의 같은데 수익률만 갈립니다.</a:t>
             </a:r>
             <a:endParaRPr lang="en-US" sz="1000" dirty="0"/>
           </a:p>
@@ -42442,7 +42520,7 @@
                 <a:ea typeface="맑은 고딕" pitchFamily="34" charset="-122"/>
                 <a:cs typeface="맑은 고딕" pitchFamily="34" charset="-120"/>
               </a:rPr>
-              <a:t>제38207회(추천 2번) — 값어치 멀쩡한 상품 중 손실 확률 1%당 수익률 1등. 이 우위가 공시 상관 0.22 하나에 얹혀 있는지 흔들어 봤습니다</a:t>
+              <a:t>제38207회(추천 2번) — 값어치 멀쩡한 상품 중 손실 확률 1%당 수익률 1등. 이 우위가 공시 상관 0.22~0.76에 얹혀 있는지 흔들어 봤습니다</a:t>
             </a:r>
             <a:endParaRPr lang="en-US" sz="1200" dirty="0"/>
           </a:p>
@@ -42497,7 +42575,7 @@
                           <a:ea typeface="맑은 고딕" pitchFamily="34" charset="-122"/>
                           <a:cs typeface="맑은 고딕" pitchFamily="34" charset="-120"/>
                         </a:rPr>
-                        <a:t>같이 움직이는 정도</a:t>
+                        <a:t>같이 움직이는 정도 (모든 쌍)</a:t>
                       </a:r>
                       <a:endParaRPr lang="en-US" sz="1100" dirty="0">
                         <a:latin typeface="맑은 고딕" charset="0"/>
@@ -42565,7 +42643,7 @@
                           <a:ea typeface="맑은 고딕" pitchFamily="34" charset="-122"/>
                           <a:cs typeface="맑은 고딕" pitchFamily="34" charset="-120"/>
                         </a:rPr>
-                        <a:t>서류값 0.22</a:t>
+                        <a:t>서류값 0.22~0.76</a:t>
                       </a:r>
                       <a:endParaRPr lang="en-US" sz="1100" dirty="0">
                         <a:latin typeface="맑은 고딕" charset="0"/>
@@ -42633,7 +42711,7 @@
                           <a:ea typeface="맑은 고딕" pitchFamily="34" charset="-122"/>
                           <a:cs typeface="맑은 고딕" pitchFamily="34" charset="-120"/>
                         </a:rPr>
-                        <a:t>0.90</a:t>
+                        <a:t>−0.1</a:t>
                       </a:r>
                       <a:endParaRPr lang="en-US" sz="1100" dirty="0">
                         <a:latin typeface="맑은 고딕" charset="0"/>
@@ -42701,7 +42779,7 @@
                           <a:ea typeface="맑은 고딕" pitchFamily="34" charset="-122"/>
                           <a:cs typeface="맑은 고딕" pitchFamily="34" charset="-120"/>
                         </a:rPr>
-                        <a:t>0.80</a:t>
+                        <a:t>−0.2</a:t>
                       </a:r>
                       <a:endParaRPr lang="en-US" sz="1100" dirty="0">
                         <a:latin typeface="맑은 고딕" charset="0"/>
@@ -42769,7 +42847,7 @@
                           <a:ea typeface="맑은 고딕" pitchFamily="34" charset="-122"/>
                           <a:cs typeface="맑은 고딕" pitchFamily="34" charset="-120"/>
                         </a:rPr>
-                        <a:t>0.70</a:t>
+                        <a:t>−0.3</a:t>
                       </a:r>
                       <a:endParaRPr lang="en-US" sz="1100" dirty="0">
                         <a:latin typeface="맑은 고딕" charset="0"/>
@@ -42837,7 +42915,7 @@
                           <a:ea typeface="맑은 고딕" pitchFamily="34" charset="-122"/>
                           <a:cs typeface="맑은 고딕" pitchFamily="34" charset="-120"/>
                         </a:rPr>
-                        <a:t>0.60</a:t>
+                        <a:t>−0.4</a:t>
                       </a:r>
                       <a:endParaRPr lang="en-US" sz="1100" dirty="0">
                         <a:latin typeface="맑은 고딕" charset="0"/>
@@ -42905,7 +42983,7 @@
                           <a:ea typeface="맑은 고딕" pitchFamily="34" charset="-122"/>
                           <a:cs typeface="맑은 고딕" pitchFamily="34" charset="-120"/>
                         </a:rPr>
-                        <a:t>0.50</a:t>
+                        <a:t>−0.5</a:t>
                       </a:r>
                       <a:endParaRPr lang="en-US" sz="1100" dirty="0">
                         <a:latin typeface="맑은 고딕" charset="0"/>
@@ -43105,7 +43183,7 @@
                           <a:ea typeface="맑은 고딕" pitchFamily="34" charset="-122"/>
                           <a:cs typeface="맑은 고딕" pitchFamily="34" charset="-120"/>
                         </a:rPr>
-                        <a:t>11.3%</a:t>
+                        <a:t>14.5%</a:t>
                       </a:r>
                       <a:endParaRPr lang="en-US" sz="1100" dirty="0">
                         <a:latin typeface="맑은 고딕" charset="0"/>
@@ -43170,7 +43248,7 @@
                           <a:ea typeface="맑은 고딕" pitchFamily="34" charset="-122"/>
                           <a:cs typeface="맑은 고딕" pitchFamily="34" charset="-120"/>
                         </a:rPr>
-                        <a:t>12.3%</a:t>
+                        <a:t>15.2%</a:t>
                       </a:r>
                       <a:endParaRPr lang="en-US" sz="1100" dirty="0">
                         <a:latin typeface="맑은 고딕" charset="0"/>
@@ -43235,7 +43313,7 @@
                           <a:ea typeface="맑은 고딕" pitchFamily="34" charset="-122"/>
                           <a:cs typeface="맑은 고딕" pitchFamily="34" charset="-120"/>
                         </a:rPr>
-                        <a:t>13.1%</a:t>
+                        <a:t>15.8%</a:t>
                       </a:r>
                       <a:endParaRPr lang="en-US" sz="1100" dirty="0">
                         <a:latin typeface="맑은 고딕" charset="0"/>
@@ -43300,7 +43378,7 @@
                           <a:ea typeface="맑은 고딕" pitchFamily="34" charset="-122"/>
                           <a:cs typeface="맑은 고딕" pitchFamily="34" charset="-120"/>
                         </a:rPr>
-                        <a:t>14.0%</a:t>
+                        <a:t>16.3%</a:t>
                       </a:r>
                       <a:endParaRPr lang="en-US" sz="1100" dirty="0">
                         <a:latin typeface="맑은 고딕" charset="0"/>
@@ -43365,7 +43443,7 @@
                           <a:ea typeface="맑은 고딕" pitchFamily="34" charset="-122"/>
                           <a:cs typeface="맑은 고딕" pitchFamily="34" charset="-120"/>
                         </a:rPr>
-                        <a:t>14.8%</a:t>
+                        <a:t>16.7%</a:t>
                       </a:r>
                       <a:endParaRPr lang="en-US" sz="1100" dirty="0">
                         <a:latin typeface="맑은 고딕" charset="0"/>
@@ -43562,7 +43640,7 @@
                           <a:ea typeface="맑은 고딕" pitchFamily="34" charset="-122"/>
                           <a:cs typeface="맑은 고딕" pitchFamily="34" charset="-120"/>
                         </a:rPr>
-                        <a:t>0.83%</a:t>
+                        <a:t>0.65%</a:t>
                       </a:r>
                       <a:endParaRPr lang="en-US" sz="1100" dirty="0">
                         <a:latin typeface="맑은 고딕" charset="0"/>
@@ -43627,7 +43705,7 @@
                           <a:ea typeface="맑은 고딕" pitchFamily="34" charset="-122"/>
                           <a:cs typeface="맑은 고딕" pitchFamily="34" charset="-120"/>
                         </a:rPr>
-                        <a:t>0.76%</a:t>
+                        <a:t>0.62%</a:t>
                       </a:r>
                       <a:endParaRPr lang="en-US" sz="1100" dirty="0">
                         <a:latin typeface="맑은 고딕" charset="0"/>
@@ -43692,7 +43770,7 @@
                           <a:ea typeface="맑은 고딕" pitchFamily="34" charset="-122"/>
                           <a:cs typeface="맑은 고딕" pitchFamily="34" charset="-120"/>
                         </a:rPr>
-                        <a:t>0.72%</a:t>
+                        <a:t>0.59%</a:t>
                       </a:r>
                       <a:endParaRPr lang="en-US" sz="1100" dirty="0">
                         <a:latin typeface="맑은 고딕" charset="0"/>
@@ -43757,7 +43835,7 @@
                           <a:ea typeface="맑은 고딕" pitchFamily="34" charset="-122"/>
                           <a:cs typeface="맑은 고딕" pitchFamily="34" charset="-120"/>
                         </a:rPr>
-                        <a:t>0.67%</a:t>
+                        <a:t>0.58%</a:t>
                       </a:r>
                       <a:endParaRPr lang="en-US" sz="1100" dirty="0">
                         <a:latin typeface="맑은 고딕" charset="0"/>
@@ -43822,7 +43900,7 @@
                           <a:ea typeface="맑은 고딕" pitchFamily="34" charset="-122"/>
                           <a:cs typeface="맑은 고딕" pitchFamily="34" charset="-120"/>
                         </a:rPr>
-                        <a:t>0.64%</a:t>
+                        <a:t>0.56%</a:t>
                       </a:r>
                       <a:endParaRPr lang="en-US" sz="1100" dirty="0">
                         <a:latin typeface="맑은 고딕" charset="0"/>
@@ -43911,7 +43989,7 @@
                 <a:ea typeface="맑은 고딕" pitchFamily="34" charset="-122"/>
                 <a:cs typeface="맑은 고딕" pitchFamily="34" charset="-120"/>
               </a:rPr>
-              <a:t>같이 움직이는 정도를 0.50까지만 낮춰도 손실 확률 1%당 수익률이 0.64%로 제38205회(0.67%)보다 낮아져 1등을 내줍니다(0.50이면 손실 확률 13.7% → 14.8%). 이 상품의 우위는 두 자산이 서류값 0.22만큼 같이 움직인다는 전제에 기대고 있습니다.</a:t>
+              <a:t>같이 움직이는 정도를 서류값보다 0.1씩만 낮춰도 손실 확률 1%당 수익률이 0.65%로 제38205회(0.67%)보다 낮아져 1등을 내줍니다(0.5씩 낮추면 손실 확률 13.7% → 16.7%). 이 상품의 우위는 세 자산이 서류에 적힌 만큼(0.22~0.76) 같이 움직인다는 전제에 기대고 있습니다. 칸 머리의 −0.1 등은 3쌍 모두를 서류값에서 그만큼 낮춘 것입니다(0 아래로는 내리지 않음).</a:t>
             </a:r>
             <a:endParaRPr lang="en-US" sz="1000" dirty="0"/>
           </a:p>
@@ -44034,7 +44112,7 @@
                 <a:ea typeface="맑은 고딕" pitchFamily="34" charset="-122"/>
                 <a:cs typeface="맑은 고딕" pitchFamily="34" charset="-120"/>
               </a:rPr>
-              <a:t>출처 — 금융감독원 전자공시시스템(DART)에 2026.10.16 올라온 투자설명서 (접수번호 20261016000319)  ·  원금을 잃을 수 있는 상품입니다</a:t>
+              <a:t>출처 — 금융감독원 전자공시시스템(DART)에 2026.10.16·2026.10.14 올라온 투자설명서 (접수번호 20261016000319 · 20261014000084)  ·  원금을 잃을 수 있는 상품입니다</a:t>
             </a:r>
             <a:endParaRPr lang="en-US" sz="850" dirty="0"/>
           </a:p>
@@ -45504,7 +45582,7 @@
                 <a:ea typeface="맑은 고딕" pitchFamily="34" charset="-122"/>
                 <a:cs typeface="맑은 고딕" pitchFamily="34" charset="-120"/>
               </a:rPr>
-              <a:t>둘이 같이 움직임 0.17</a:t>
+              <a:t>가장 따로 노는 쌍 0.17</a:t>
             </a:r>
             <a:endParaRPr lang="en-US" sz="950" dirty="0"/>
           </a:p>
@@ -45621,7 +45699,7 @@
                 <a:ea typeface="맑은 고딕" pitchFamily="34" charset="-122"/>
                 <a:cs typeface="맑은 고딕" pitchFamily="34" charset="-120"/>
               </a:rPr>
-              <a:t>출처 — 금융감독원 전자공시시스템(DART)에 2026.10.16 올라온 투자설명서 (접수번호 20261016000319)  ·  원금을 잃을 수 있는 상품입니다</a:t>
+              <a:t>출처 — 금융감독원 전자공시시스템(DART)에 2026.10.16·2026.10.14 올라온 투자설명서 (접수번호 20261016000319 · 20261014000084)  ·  원금을 잃을 수 있는 상품입니다</a:t>
             </a:r>
             <a:endParaRPr lang="en-US" sz="850" dirty="0"/>
           </a:p>

</xml_diff>

<commit_message>
feat(els): 제38225~38241회 17종 세일즈 자료 3종 (자동 빌드)
러너가 수집·파싱·대장 검산·빌드·역방향 대조까지 끝낸 판이다. 눈으로 보는 검증은 아직 안 했다 — 예약 세션이 받아서 확인하고 사용자에게 보낸다.

접수번호 20261023000173
</commit_message>
<xml_diff>
--- a/els-analysis-deck.pptx
+++ b/els-analysis-deck.pptx
@@ -6239,7 +6239,7 @@
                 <a:ea typeface="맑은 고딕" pitchFamily="34" charset="-122"/>
                 <a:cs typeface="맑은 고딕" pitchFamily="34" charset="-120"/>
               </a:rPr>
-              <a:t>홈페이지 확인 2026.10.26(월) 08:21 — 현재 청약 진행중 18건.  개인 일반투자자 청약 마감은 10월 30일(금)입니다.</a:t>
+              <a:t>홈페이지 확인 2026.10.26(월) 08:28 — 현재 청약 진행중 18건.  개인 일반투자자 청약 마감은 10월 30일(금)입니다.</a:t>
             </a:r>
             <a:endParaRPr lang="en-US" sz="1200" dirty="0"/>
           </a:p>
@@ -7787,7 +7787,7 @@
                 <a:ea typeface="맑은 고딕" pitchFamily="34" charset="-122"/>
                 <a:cs typeface="맑은 고딕" pitchFamily="34" charset="-120"/>
               </a:rPr>
-              <a:t>지는 위험 1%당 받는 수익률이 권할 수 있는 상품 중에서 가장 큽니다 — 같은 위험이면 그만큼 많이 줍니다.</a:t>
+              <a:t>지는 위험 1%당 받는 수익률이 값어치 멀쩡한 상품 중에서는 앞 자리에 오른 제38226회 다음으로 큽니다 — 같은 위험이면 그만큼 많이 줍니다.</a:t>
             </a:r>
             <a:endParaRPr lang="en-US" sz="1150" dirty="0"/>
           </a:p>

</xml_diff>